<commit_message>
all brochire styling and wording and selection all look great now.
</commit_message>
<xml_diff>
--- a/Brochure_Template.pptx
+++ b/Brochure_Template.pptx
@@ -43,7 +43,7 @@
         <p:spPr>
           <a:xfrm>
             <a:off x="502920" y="820800"/>
-            <a:ext cx="9051840" cy="274680"/>
+            <a:ext cx="9051480" cy="274680"/>
           </a:xfrm>
           <a:prstGeom prst="rect">
             <a:avLst/>
@@ -59,7 +59,13 @@
           </a:bodyPr>
           <a:p>
             <a:pPr indent="0">
+              <a:lnSpc>
+                <a:spcPct val="100000"/>
+              </a:lnSpc>
               <a:buNone/>
+              <a:tabLst>
+                <a:tab algn="l" pos="0"/>
+              </a:tabLst>
             </a:pPr>
             <a:r>
               <a:rPr lang="en-CA" sz="1800" b="0" u="none" strike="noStrike">
@@ -96,7 +102,7 @@
         <p:spPr>
           <a:xfrm>
             <a:off x="502920" y="1818000"/>
-            <a:ext cx="9051840" cy="4507200"/>
+            <a:ext cx="9051480" cy="4506840"/>
           </a:xfrm>
           <a:prstGeom prst="rect">
             <a:avLst/>
@@ -112,6 +118,9 @@
           </a:bodyPr>
           <a:p>
             <a:pPr marL="432000" indent="-324000">
+              <a:lnSpc>
+                <a:spcPct val="100000"/>
+              </a:lnSpc>
               <a:spcBef>
                 <a:spcPts val="1417"/>
               </a:spcBef>
@@ -144,6 +153,9 @@
           </a:p>
           <a:p>
             <a:pPr marL="864000" lvl="1" indent="-324000">
+              <a:lnSpc>
+                <a:spcPct val="100000"/>
+              </a:lnSpc>
               <a:spcBef>
                 <a:spcPts val="1134"/>
               </a:spcBef>
@@ -176,6 +188,9 @@
           </a:p>
           <a:p>
             <a:pPr marL="1296000" lvl="2" indent="-288000">
+              <a:lnSpc>
+                <a:spcPct val="100000"/>
+              </a:lnSpc>
               <a:spcBef>
                 <a:spcPts val="850"/>
               </a:spcBef>
@@ -208,6 +223,9 @@
           </a:p>
           <a:p>
             <a:pPr marL="1728000" lvl="3" indent="-216000">
+              <a:lnSpc>
+                <a:spcPct val="100000"/>
+              </a:lnSpc>
               <a:spcBef>
                 <a:spcPts val="567"/>
               </a:spcBef>
@@ -240,6 +258,9 @@
           </a:p>
           <a:p>
             <a:pPr marL="2160000" lvl="4" indent="-216000">
+              <a:lnSpc>
+                <a:spcPct val="100000"/>
+              </a:lnSpc>
               <a:spcBef>
                 <a:spcPts val="283"/>
               </a:spcBef>
@@ -272,6 +293,9 @@
           </a:p>
           <a:p>
             <a:pPr marL="2592000" lvl="5" indent="-216000">
+              <a:lnSpc>
+                <a:spcPct val="100000"/>
+              </a:lnSpc>
               <a:spcBef>
                 <a:spcPts val="283"/>
               </a:spcBef>
@@ -304,6 +328,9 @@
           </a:p>
           <a:p>
             <a:pPr marL="3024000" lvl="6" indent="-216000">
+              <a:lnSpc>
+                <a:spcPct val="100000"/>
+              </a:lnSpc>
               <a:spcBef>
                 <a:spcPts val="283"/>
               </a:spcBef>
@@ -349,7 +376,7 @@
         <p:spPr>
           <a:xfrm>
             <a:off x="3439440" y="7080120"/>
-            <a:ext cx="3187800" cy="535320"/>
+            <a:ext cx="3187440" cy="534960"/>
           </a:xfrm>
           <a:prstGeom prst="rect">
             <a:avLst/>
@@ -427,7 +454,7 @@
         <p:spPr>
           <a:xfrm>
             <a:off x="7211160" y="7080120"/>
-            <a:ext cx="2342880" cy="535320"/>
+            <a:ext cx="2342520" cy="534960"/>
           </a:xfrm>
           <a:prstGeom prst="rect">
             <a:avLst/>
@@ -470,7 +497,7 @@
                 <a:tab algn="l" pos="0"/>
               </a:tabLst>
             </a:pPr>
-            <a:fld id="{81952E31-A23B-4DEC-8964-D0E38E3DDF2D}" type="slidenum">
+            <a:fld id="{190B3A3F-89E4-4D28-AAD4-4D349F5C9963}" type="slidenum">
               <a:rPr lang="en-CA" sz="1400" b="0" u="none" strike="noStrike">
                 <a:solidFill>
                   <a:srgbClr val="000000"/>
@@ -505,7 +532,7 @@
         <p:spPr>
           <a:xfrm>
             <a:off x="502920" y="7080120"/>
-            <a:ext cx="2342880" cy="535320"/>
+            <a:ext cx="2342520" cy="534960"/>
           </a:xfrm>
           <a:prstGeom prst="rect">
             <a:avLst/>
@@ -521,7 +548,13 @@
           </a:bodyPr>
           <a:lstStyle>
             <a:lvl1pPr indent="0">
+              <a:lnSpc>
+                <a:spcPct val="100000"/>
+              </a:lnSpc>
               <a:buNone/>
+              <a:tabLst>
+                <a:tab algn="l" pos="0"/>
+              </a:tabLst>
               <a:defRPr lang="en-CA" sz="1400" b="0" u="none" strike="noStrike">
                 <a:solidFill>
                   <a:srgbClr val="000000"/>
@@ -534,7 +567,13 @@
           </a:lstStyle>
           <a:p>
             <a:pPr indent="0">
+              <a:lnSpc>
+                <a:spcPct val="100000"/>
+              </a:lnSpc>
               <a:buNone/>
+              <a:tabLst>
+                <a:tab algn="l" pos="0"/>
+              </a:tabLst>
             </a:pPr>
             <a:r>
               <a:rPr lang="en-CA" sz="1400" b="0" u="none" strike="noStrike">
@@ -593,7 +632,7 @@
         <p:spPr>
           <a:xfrm>
             <a:off x="502920" y="820800"/>
-            <a:ext cx="9051840" cy="274680"/>
+            <a:ext cx="9051480" cy="274680"/>
           </a:xfrm>
           <a:prstGeom prst="rect">
             <a:avLst/>
@@ -609,7 +648,13 @@
           </a:bodyPr>
           <a:p>
             <a:pPr indent="0">
+              <a:lnSpc>
+                <a:spcPct val="100000"/>
+              </a:lnSpc>
               <a:buNone/>
+              <a:tabLst>
+                <a:tab algn="l" pos="0"/>
+              </a:tabLst>
             </a:pPr>
             <a:r>
               <a:rPr lang="en-CA" sz="1800" b="0" u="none" strike="noStrike">
@@ -646,7 +691,7 @@
         <p:spPr>
           <a:xfrm>
             <a:off x="3439440" y="7080120"/>
-            <a:ext cx="3187800" cy="535320"/>
+            <a:ext cx="3187440" cy="534960"/>
           </a:xfrm>
           <a:prstGeom prst="rect">
             <a:avLst/>
@@ -724,7 +769,7 @@
         <p:spPr>
           <a:xfrm>
             <a:off x="7211160" y="7080120"/>
-            <a:ext cx="2342880" cy="535320"/>
+            <a:ext cx="2342520" cy="534960"/>
           </a:xfrm>
           <a:prstGeom prst="rect">
             <a:avLst/>
@@ -767,7 +812,7 @@
                 <a:tab algn="l" pos="0"/>
               </a:tabLst>
             </a:pPr>
-            <a:fld id="{7DF18875-C1AF-4AC0-BC80-21A96445EAB5}" type="slidenum">
+            <a:fld id="{3FBE0CCD-27BA-4FD2-A4CA-60195DFF7F81}" type="slidenum">
               <a:rPr lang="en-CA" sz="1400" b="0" u="none" strike="noStrike">
                 <a:solidFill>
                   <a:srgbClr val="000000"/>
@@ -802,7 +847,7 @@
         <p:spPr>
           <a:xfrm>
             <a:off x="502920" y="7080120"/>
-            <a:ext cx="2342880" cy="535320"/>
+            <a:ext cx="2342520" cy="534960"/>
           </a:xfrm>
           <a:prstGeom prst="rect">
             <a:avLst/>
@@ -818,7 +863,13 @@
           </a:bodyPr>
           <a:lstStyle>
             <a:lvl1pPr indent="0">
+              <a:lnSpc>
+                <a:spcPct val="100000"/>
+              </a:lnSpc>
               <a:buNone/>
+              <a:tabLst>
+                <a:tab algn="l" pos="0"/>
+              </a:tabLst>
               <a:defRPr lang="en-CA" sz="1400" b="0" u="none" strike="noStrike">
                 <a:solidFill>
                   <a:srgbClr val="000000"/>
@@ -831,7 +882,13 @@
           </a:lstStyle>
           <a:p>
             <a:pPr indent="0">
+              <a:lnSpc>
+                <a:spcPct val="100000"/>
+              </a:lnSpc>
               <a:buNone/>
+              <a:tabLst>
+                <a:tab algn="l" pos="0"/>
+              </a:tabLst>
             </a:pPr>
             <a:r>
               <a:rPr lang="en-CA" sz="1400" b="0" u="none" strike="noStrike">
@@ -868,7 +925,7 @@
         <p:spPr>
           <a:xfrm>
             <a:off x="502920" y="1818720"/>
-            <a:ext cx="9052200" cy="4507560"/>
+            <a:ext cx="9051840" cy="4507200"/>
           </a:xfrm>
           <a:prstGeom prst="rect">
             <a:avLst/>
@@ -884,6 +941,9 @@
           </a:bodyPr>
           <a:p>
             <a:pPr marL="432000" indent="-324000">
+              <a:lnSpc>
+                <a:spcPct val="100000"/>
+              </a:lnSpc>
               <a:spcBef>
                 <a:spcPts val="1417"/>
               </a:spcBef>
@@ -916,6 +976,9 @@
           </a:p>
           <a:p>
             <a:pPr marL="864000" lvl="1" indent="-324000">
+              <a:lnSpc>
+                <a:spcPct val="100000"/>
+              </a:lnSpc>
               <a:spcBef>
                 <a:spcPts val="1134"/>
               </a:spcBef>
@@ -948,6 +1011,9 @@
           </a:p>
           <a:p>
             <a:pPr marL="1296000" lvl="2" indent="-288000">
+              <a:lnSpc>
+                <a:spcPct val="100000"/>
+              </a:lnSpc>
               <a:spcBef>
                 <a:spcPts val="850"/>
               </a:spcBef>
@@ -980,6 +1046,9 @@
           </a:p>
           <a:p>
             <a:pPr marL="1728000" lvl="3" indent="-216000">
+              <a:lnSpc>
+                <a:spcPct val="100000"/>
+              </a:lnSpc>
               <a:spcBef>
                 <a:spcPts val="567"/>
               </a:spcBef>
@@ -1012,6 +1081,9 @@
           </a:p>
           <a:p>
             <a:pPr marL="2160000" lvl="4" indent="-216000">
+              <a:lnSpc>
+                <a:spcPct val="100000"/>
+              </a:lnSpc>
               <a:spcBef>
                 <a:spcPts val="283"/>
               </a:spcBef>
@@ -1044,6 +1116,9 @@
           </a:p>
           <a:p>
             <a:pPr marL="2592000" lvl="5" indent="-216000">
+              <a:lnSpc>
+                <a:spcPct val="100000"/>
+              </a:lnSpc>
               <a:spcBef>
                 <a:spcPts val="283"/>
               </a:spcBef>
@@ -1076,6 +1151,9 @@
           </a:p>
           <a:p>
             <a:pPr marL="3024000" lvl="6" indent="-216000">
+              <a:lnSpc>
+                <a:spcPct val="100000"/>
+              </a:lnSpc>
               <a:spcBef>
                 <a:spcPts val="283"/>
               </a:spcBef>
@@ -1173,8 +1251,8 @@
         </p:nvSpPr>
         <p:spPr>
           <a:xfrm>
-            <a:off x="244800" y="282600"/>
-            <a:ext cx="996480" cy="1345680"/>
+            <a:off x="244800" y="757080"/>
+            <a:ext cx="996120" cy="396000"/>
           </a:xfrm>
           <a:prstGeom prst="rect">
             <a:avLst/>
@@ -1191,7 +1269,7 @@
           <a:fontRef idx="minor"/>
         </p:style>
         <p:txBody>
-          <a:bodyPr lIns="90000" rIns="90000" tIns="45000" bIns="45000" anchor="t" anchorCtr="1">
+          <a:bodyPr lIns="90000" rIns="90000" tIns="45000" bIns="45000" anchor="ctr" anchorCtr="1">
             <a:spAutoFit/>
           </a:bodyPr>
           <a:p>
@@ -1208,6 +1286,7 @@
                 <a:effectLst/>
                 <a:uFillTx/>
                 <a:latin typeface="Nimbus Roman"/>
+                <a:ea typeface="DejaVu Sans"/>
               </a:rPr>
               <a:t>{{caption_1}}</a:t>
             </a:r>
@@ -1245,8 +1324,8 @@
         </p:nvSpPr>
         <p:spPr>
           <a:xfrm>
-            <a:off x="2037600" y="1746360"/>
-            <a:ext cx="996480" cy="1405440"/>
+            <a:off x="2037600" y="2250720"/>
+            <a:ext cx="996120" cy="396000"/>
           </a:xfrm>
           <a:prstGeom prst="rect">
             <a:avLst/>
@@ -1263,7 +1342,7 @@
           <a:fontRef idx="minor"/>
         </p:style>
         <p:txBody>
-          <a:bodyPr lIns="90000" rIns="90000" tIns="45000" bIns="45000" anchor="t" anchorCtr="1">
+          <a:bodyPr lIns="90000" rIns="90000" tIns="45000" bIns="45000" anchor="ctr" anchorCtr="1">
             <a:spAutoFit/>
           </a:bodyPr>
           <a:p>
@@ -1280,6 +1359,7 @@
                 <a:effectLst/>
                 <a:uFillTx/>
                 <a:latin typeface="Nimbus Roman"/>
+                <a:ea typeface="DejaVu Sans"/>
               </a:rPr>
               <a:t>{{caption_2}}</a:t>
             </a:r>
@@ -1317,8 +1397,8 @@
         </p:nvSpPr>
         <p:spPr>
           <a:xfrm>
-            <a:off x="254160" y="3244320"/>
-            <a:ext cx="996480" cy="1345680"/>
+            <a:off x="254160" y="3718800"/>
+            <a:ext cx="996120" cy="396000"/>
           </a:xfrm>
           <a:prstGeom prst="rect">
             <a:avLst/>
@@ -1335,7 +1415,7 @@
           <a:fontRef idx="minor"/>
         </p:style>
         <p:txBody>
-          <a:bodyPr lIns="90000" rIns="90000" tIns="45000" bIns="45000" anchor="t" anchorCtr="1">
+          <a:bodyPr lIns="90000" rIns="90000" tIns="45000" bIns="45000" anchor="ctr" anchorCtr="1">
             <a:spAutoFit/>
           </a:bodyPr>
           <a:p>
@@ -1352,6 +1432,7 @@
                 <a:effectLst/>
                 <a:uFillTx/>
                 <a:latin typeface="Nimbus Roman"/>
+                <a:ea typeface="DejaVu Sans"/>
               </a:rPr>
               <a:t>{{caption_3}}</a:t>
             </a:r>
@@ -1389,8 +1470,8 @@
         </p:nvSpPr>
         <p:spPr>
           <a:xfrm>
-            <a:off x="1995120" y="4647600"/>
-            <a:ext cx="996480" cy="1345680"/>
+            <a:off x="1995120" y="5122080"/>
+            <a:ext cx="996120" cy="396000"/>
           </a:xfrm>
           <a:prstGeom prst="rect">
             <a:avLst/>
@@ -1407,7 +1488,7 @@
           <a:fontRef idx="minor"/>
         </p:style>
         <p:txBody>
-          <a:bodyPr lIns="90000" rIns="90000" tIns="45000" bIns="45000" anchor="t" anchorCtr="1">
+          <a:bodyPr lIns="90000" rIns="90000" tIns="45000" bIns="45000" anchor="ctr" anchorCtr="1">
             <a:spAutoFit/>
           </a:bodyPr>
           <a:p>
@@ -1424,6 +1505,7 @@
                 <a:effectLst/>
                 <a:uFillTx/>
                 <a:latin typeface="Nimbus Roman"/>
+                <a:ea typeface="DejaVu Sans"/>
               </a:rPr>
               <a:t>{{caption_4}}</a:t>
             </a:r>
@@ -1461,8 +1543,8 @@
         </p:nvSpPr>
         <p:spPr>
           <a:xfrm>
-            <a:off x="280440" y="6067800"/>
-            <a:ext cx="996480" cy="1345680"/>
+            <a:off x="280440" y="6542280"/>
+            <a:ext cx="996120" cy="396000"/>
           </a:xfrm>
           <a:prstGeom prst="rect">
             <a:avLst/>
@@ -1479,7 +1561,7 @@
           <a:fontRef idx="minor"/>
         </p:style>
         <p:txBody>
-          <a:bodyPr lIns="90000" rIns="90000" tIns="45000" bIns="45000" anchor="t" anchorCtr="1">
+          <a:bodyPr lIns="90000" rIns="90000" tIns="45000" bIns="45000" anchor="ctr" anchorCtr="1">
             <a:spAutoFit/>
           </a:bodyPr>
           <a:p>
@@ -1496,6 +1578,7 @@
                 <a:effectLst/>
                 <a:uFillTx/>
                 <a:latin typeface="Nimbus Roman"/>
+                <a:ea typeface="DejaVu Sans"/>
               </a:rPr>
               <a:t>{{caption_5}}</a:t>
             </a:r>
@@ -1534,7 +1617,7 @@
         <p:spPr>
           <a:xfrm>
             <a:off x="1255320" y="270000"/>
-            <a:ext cx="1765440" cy="1357920"/>
+            <a:ext cx="1765080" cy="1357560"/>
           </a:xfrm>
           <a:prstGeom prst="rect">
             <a:avLst/>
@@ -1583,7 +1666,7 @@
         <p:spPr>
           <a:xfrm>
             <a:off x="240480" y="1755720"/>
-            <a:ext cx="1801440" cy="1410840"/>
+            <a:ext cx="1801080" cy="1410480"/>
           </a:xfrm>
           <a:prstGeom prst="rect">
             <a:avLst/>
@@ -1632,7 +1715,7 @@
         <p:spPr>
           <a:xfrm>
             <a:off x="239760" y="4661640"/>
-            <a:ext cx="1703520" cy="1334160"/>
+            <a:ext cx="1703160" cy="1333800"/>
           </a:xfrm>
           <a:prstGeom prst="rect">
             <a:avLst/>
@@ -1681,7 +1764,7 @@
         <p:spPr>
           <a:xfrm>
             <a:off x="1319760" y="3267720"/>
-            <a:ext cx="1699920" cy="1303920"/>
+            <a:ext cx="1699560" cy="1303560"/>
           </a:xfrm>
           <a:prstGeom prst="rect">
             <a:avLst/>
@@ -1730,7 +1813,7 @@
         <p:spPr>
           <a:xfrm>
             <a:off x="1380960" y="6063840"/>
-            <a:ext cx="1640160" cy="1285560"/>
+            <a:ext cx="1639800" cy="1285200"/>
           </a:xfrm>
           <a:prstGeom prst="rect">
             <a:avLst/>
@@ -1779,7 +1862,7 @@
         <p:spPr>
           <a:xfrm>
             <a:off x="3778200" y="341280"/>
-            <a:ext cx="2587320" cy="444240"/>
+            <a:ext cx="2586960" cy="443880"/>
           </a:xfrm>
           <a:prstGeom prst="rect">
             <a:avLst/>
@@ -1837,7 +1920,7 @@
         <p:spPr>
           <a:xfrm>
             <a:off x="3651120" y="785880"/>
-            <a:ext cx="2825280" cy="5513760"/>
+            <a:ext cx="2824920" cy="5513400"/>
           </a:xfrm>
           <a:prstGeom prst="rect">
             <a:avLst/>
@@ -1877,6 +1960,7 @@
                 <a:effectLst/>
                 <a:uFillTx/>
                 <a:latin typeface="Nimbus Roman"/>
+                <a:ea typeface="DejaVu Sans"/>
               </a:rPr>
               <a:t>{{SUMMARY}}</a:t>
             </a:r>
@@ -1900,7 +1984,7 @@
         <p:spPr>
           <a:xfrm>
             <a:off x="7111800" y="1428840"/>
-            <a:ext cx="2587320" cy="444240"/>
+            <a:ext cx="2586960" cy="443880"/>
           </a:xfrm>
           <a:prstGeom prst="rect">
             <a:avLst/>
@@ -1958,7 +2042,7 @@
         <p:spPr>
           <a:xfrm>
             <a:off x="7064640" y="2086920"/>
-            <a:ext cx="2665440" cy="1936800"/>
+            <a:ext cx="2665080" cy="1936440"/>
           </a:xfrm>
           <a:prstGeom prst="rect">
             <a:avLst/>
@@ -2009,7 +2093,7 @@
         <p:spPr>
           <a:xfrm>
             <a:off x="7139160" y="4844520"/>
-            <a:ext cx="2587320" cy="444240"/>
+            <a:ext cx="2586960" cy="443880"/>
           </a:xfrm>
           <a:prstGeom prst="rect">
             <a:avLst/>
@@ -2043,6 +2127,7 @@
                 <a:effectLst/>
                 <a:uFillTx/>
                 <a:latin typeface="Nimbus Roman"/>
+                <a:ea typeface="DejaVu Sans"/>
               </a:rPr>
               <a:t>{{TITLE}}</a:t>
             </a:r>
@@ -2066,7 +2151,7 @@
         <p:spPr>
           <a:xfrm>
             <a:off x="7132320" y="6575400"/>
-            <a:ext cx="2587320" cy="444240"/>
+            <a:ext cx="2586960" cy="443880"/>
           </a:xfrm>
           <a:prstGeom prst="rect">
             <a:avLst/>
@@ -2100,6 +2185,7 @@
                 <a:effectLst/>
                 <a:uFillTx/>
                 <a:latin typeface="Nimbus Roman"/>
+                <a:ea typeface="DejaVu Sans"/>
               </a:rPr>
               <a:t>{{PRICE}}</a:t>
             </a:r>
@@ -2123,7 +2209,7 @@
         <p:spPr>
           <a:xfrm>
             <a:off x="7132320" y="6130800"/>
-            <a:ext cx="2587320" cy="444240"/>
+            <a:ext cx="2586960" cy="443880"/>
           </a:xfrm>
           <a:prstGeom prst="rect">
             <a:avLst/>
@@ -2157,6 +2243,7 @@
                 <a:effectLst/>
                 <a:uFillTx/>
                 <a:latin typeface="Nimbus Roman"/>
+                <a:ea typeface="DejaVu Sans"/>
               </a:rPr>
               <a:t>{{BEDS_AND_BATHS}}</a:t>
             </a:r>
@@ -2218,7 +2305,7 @@
         <p:spPr>
           <a:xfrm>
             <a:off x="1322640" y="241560"/>
-            <a:ext cx="1697760" cy="1311480"/>
+            <a:ext cx="1697400" cy="1311120"/>
           </a:xfrm>
           <a:prstGeom prst="rect">
             <a:avLst/>
@@ -2267,7 +2354,7 @@
         <p:spPr>
           <a:xfrm>
             <a:off x="329760" y="1672920"/>
-            <a:ext cx="1645560" cy="1323000"/>
+            <a:ext cx="1645200" cy="1322640"/>
           </a:xfrm>
           <a:prstGeom prst="rect">
             <a:avLst/>
@@ -2316,7 +2403,7 @@
         <p:spPr>
           <a:xfrm>
             <a:off x="1323360" y="3106080"/>
-            <a:ext cx="1697040" cy="1374480"/>
+            <a:ext cx="1696680" cy="1374120"/>
           </a:xfrm>
           <a:prstGeom prst="rect">
             <a:avLst/>
@@ -2365,7 +2452,7 @@
         <p:spPr>
           <a:xfrm>
             <a:off x="289800" y="4596840"/>
-            <a:ext cx="1589040" cy="1460880"/>
+            <a:ext cx="1588680" cy="1460520"/>
           </a:xfrm>
           <a:prstGeom prst="rect">
             <a:avLst/>
@@ -2414,7 +2501,7 @@
         <p:spPr>
           <a:xfrm>
             <a:off x="1332000" y="6153840"/>
-            <a:ext cx="1695960" cy="1310040"/>
+            <a:ext cx="1695600" cy="1309680"/>
           </a:xfrm>
           <a:prstGeom prst="rect">
             <a:avLst/>
@@ -2462,8 +2549,8 @@
         </p:nvSpPr>
         <p:spPr>
           <a:xfrm>
-            <a:off x="315720" y="224640"/>
-            <a:ext cx="996480" cy="1345680"/>
+            <a:off x="315720" y="699120"/>
+            <a:ext cx="996120" cy="396000"/>
           </a:xfrm>
           <a:prstGeom prst="rect">
             <a:avLst/>
@@ -2480,7 +2567,7 @@
           <a:fontRef idx="minor"/>
         </p:style>
         <p:txBody>
-          <a:bodyPr lIns="90000" rIns="90000" tIns="45000" bIns="45000" anchor="t" anchorCtr="1">
+          <a:bodyPr lIns="90000" rIns="90000" tIns="45000" bIns="45000" anchor="ctr" anchorCtr="1">
             <a:spAutoFit/>
           </a:bodyPr>
           <a:p>
@@ -2497,6 +2584,7 @@
                 <a:effectLst/>
                 <a:uFillTx/>
                 <a:latin typeface="Nimbus Roman"/>
+                <a:ea typeface="DejaVu Sans"/>
               </a:rPr>
               <a:t>{{caption_6}}</a:t>
             </a:r>
@@ -2534,8 +2622,8 @@
         </p:nvSpPr>
         <p:spPr>
           <a:xfrm>
-            <a:off x="1975680" y="1650240"/>
-            <a:ext cx="1045440" cy="1336680"/>
+            <a:off x="1975680" y="2120400"/>
+            <a:ext cx="1045080" cy="396000"/>
           </a:xfrm>
           <a:prstGeom prst="rect">
             <a:avLst/>
@@ -2552,7 +2640,7 @@
           <a:fontRef idx="minor"/>
         </p:style>
         <p:txBody>
-          <a:bodyPr lIns="90000" rIns="90000" tIns="45000" bIns="45000" anchor="t" anchorCtr="1">
+          <a:bodyPr lIns="90000" rIns="90000" tIns="45000" bIns="45000" anchor="ctr" anchorCtr="1">
             <a:spAutoFit/>
           </a:bodyPr>
           <a:p>
@@ -2569,6 +2657,7 @@
                 <a:effectLst/>
                 <a:uFillTx/>
                 <a:latin typeface="Nimbus Roman"/>
+                <a:ea typeface="DejaVu Sans"/>
               </a:rPr>
               <a:t>{{caption_7}}</a:t>
             </a:r>
@@ -2606,8 +2695,8 @@
         </p:nvSpPr>
         <p:spPr>
           <a:xfrm>
-            <a:off x="289800" y="3106080"/>
-            <a:ext cx="1033200" cy="1370520"/>
+            <a:off x="289800" y="3593160"/>
+            <a:ext cx="1032840" cy="396000"/>
           </a:xfrm>
           <a:prstGeom prst="rect">
             <a:avLst/>
@@ -2624,7 +2713,7 @@
           <a:fontRef idx="minor"/>
         </p:style>
         <p:txBody>
-          <a:bodyPr lIns="90000" rIns="90000" tIns="45000" bIns="45000" anchor="t" anchorCtr="1">
+          <a:bodyPr lIns="90000" rIns="90000" tIns="45000" bIns="45000" anchor="ctr" anchorCtr="1">
             <a:spAutoFit/>
           </a:bodyPr>
           <a:p>
@@ -2641,6 +2730,7 @@
                 <a:effectLst/>
                 <a:uFillTx/>
                 <a:latin typeface="Nimbus Roman"/>
+                <a:ea typeface="DejaVu Sans"/>
               </a:rPr>
               <a:t>{{caption_8}}</a:t>
             </a:r>
@@ -2678,8 +2768,8 @@
         </p:nvSpPr>
         <p:spPr>
           <a:xfrm>
-            <a:off x="308520" y="6153840"/>
-            <a:ext cx="1023120" cy="1317240"/>
+            <a:off x="308520" y="6614280"/>
+            <a:ext cx="1022760" cy="396000"/>
           </a:xfrm>
           <a:prstGeom prst="rect">
             <a:avLst/>
@@ -2696,7 +2786,7 @@
           <a:fontRef idx="minor"/>
         </p:style>
         <p:txBody>
-          <a:bodyPr lIns="90000" rIns="90000" tIns="45000" bIns="45000" anchor="t" anchorCtr="1">
+          <a:bodyPr lIns="90000" rIns="90000" tIns="45000" bIns="45000" anchor="ctr" anchorCtr="1">
             <a:spAutoFit/>
           </a:bodyPr>
           <a:p>
@@ -2713,6 +2803,7 @@
                 <a:effectLst/>
                 <a:uFillTx/>
                 <a:latin typeface="Nimbus Roman"/>
+                <a:ea typeface="DejaVu Sans"/>
               </a:rPr>
               <a:t>{{caption_10}}</a:t>
             </a:r>
@@ -2750,8 +2841,8 @@
         </p:nvSpPr>
         <p:spPr>
           <a:xfrm>
-            <a:off x="1879200" y="4596840"/>
-            <a:ext cx="1149480" cy="1464480"/>
+            <a:off x="1879200" y="5130720"/>
+            <a:ext cx="1149120" cy="396000"/>
           </a:xfrm>
           <a:prstGeom prst="rect">
             <a:avLst/>
@@ -2768,7 +2859,7 @@
           <a:fontRef idx="minor"/>
         </p:style>
         <p:txBody>
-          <a:bodyPr lIns="90000" rIns="90000" tIns="45000" bIns="45000" anchor="t" anchorCtr="1">
+          <a:bodyPr lIns="90000" rIns="90000" tIns="45000" bIns="45000" anchor="ctr" anchorCtr="1">
             <a:spAutoFit/>
           </a:bodyPr>
           <a:p>
@@ -2785,6 +2876,7 @@
                 <a:effectLst/>
                 <a:uFillTx/>
                 <a:latin typeface="Nimbus Roman"/>
+                <a:ea typeface="DejaVu Sans"/>
               </a:rPr>
               <a:t>{{caption_9}}</a:t>
             </a:r>
@@ -2823,7 +2915,7 @@
         <p:spPr>
           <a:xfrm>
             <a:off x="3778200" y="341640"/>
-            <a:ext cx="2587320" cy="444240"/>
+            <a:ext cx="2586960" cy="443880"/>
           </a:xfrm>
           <a:prstGeom prst="rect">
             <a:avLst/>
@@ -2881,7 +2973,7 @@
         <p:spPr>
           <a:xfrm>
             <a:off x="7132320" y="342000"/>
-            <a:ext cx="2587320" cy="444240"/>
+            <a:ext cx="2586960" cy="443880"/>
           </a:xfrm>
           <a:prstGeom prst="rect">
             <a:avLst/>
@@ -2939,7 +3031,7 @@
         <p:spPr>
           <a:xfrm>
             <a:off x="3600000" y="786240"/>
-            <a:ext cx="2931120" cy="6593400"/>
+            <a:ext cx="2930760" cy="6593040"/>
           </a:xfrm>
           <a:prstGeom prst="rect">
             <a:avLst/>
@@ -2979,6 +3071,7 @@
                 <a:effectLst/>
                 <a:uFillTx/>
                 <a:latin typeface="Nimbus Roman"/>
+                <a:ea typeface="DejaVu Sans"/>
               </a:rPr>
               <a:t>{{FEATURE_BLOCK}}</a:t>
             </a:r>
@@ -3002,7 +3095,7 @@
         <p:spPr>
           <a:xfrm>
             <a:off x="6966720" y="768960"/>
-            <a:ext cx="2952360" cy="410400"/>
+            <a:ext cx="2952000" cy="409680"/>
           </a:xfrm>
           <a:prstGeom prst="rect">
             <a:avLst/>
@@ -3039,6 +3132,7 @@
                 <a:effectLst/>
                 <a:uFillTx/>
                 <a:latin typeface="Nimbus Roman"/>
+                <a:ea typeface="DejaVu Sans"/>
               </a:rPr>
               <a:t>{{ROOM_BLOCK}}</a:t>
             </a:r>
@@ -3062,7 +3156,7 @@
         <p:spPr>
           <a:xfrm>
             <a:off x="7091640" y="6444720"/>
-            <a:ext cx="2587320" cy="444240"/>
+            <a:ext cx="2586960" cy="443880"/>
           </a:xfrm>
           <a:prstGeom prst="rect">
             <a:avLst/>
@@ -3096,6 +3190,7 @@
                 <a:effectLst/>
                 <a:uFillTx/>
                 <a:latin typeface="Nimbus Roman"/>
+                <a:ea typeface="DejaVu Sans"/>
               </a:rPr>
               <a:t>{{TOTAL}}</a:t>
             </a:r>

</xml_diff>